<commit_message>
lap[top updates for weihai
</commit_message>
<xml_diff>
--- a/ppt files/Weihai_v2.pptx
+++ b/ppt files/Weihai_v2.pptx
@@ -13,10 +13,10 @@
     <p:sldId id="262" r:id="rId7"/>
     <p:sldId id="263" r:id="rId8"/>
     <p:sldId id="264" r:id="rId9"/>
-    <p:sldId id="287" r:id="rId10"/>
-    <p:sldId id="288" r:id="rId11"/>
-    <p:sldId id="289" r:id="rId12"/>
-    <p:sldId id="290" r:id="rId13"/>
+    <p:sldId id="266" r:id="rId10"/>
+    <p:sldId id="267" r:id="rId11"/>
+    <p:sldId id="268" r:id="rId12"/>
+    <p:sldId id="269" r:id="rId13"/>
     <p:sldId id="271" r:id="rId14"/>
     <p:sldId id="272" r:id="rId15"/>
     <p:sldId id="273" r:id="rId16"/>
@@ -329,7 +329,7 @@
           <a:p>
             <a:fld id="{5BCAD085-E8A6-8845-BD4E-CB4CCA059FC4}" type="datetimeFigureOut">
               <a:rPr lang="en-US" smtClean="0"/>
-              <a:t>8/11/2026</a:t>
+              <a:t>8/25/2026</a:t>
             </a:fld>
             <a:endParaRPr lang="en-US"/>
           </a:p>
@@ -497,7 +497,7 @@
           <a:p>
             <a:fld id="{5BCAD085-E8A6-8845-BD4E-CB4CCA059FC4}" type="datetimeFigureOut">
               <a:rPr lang="en-US" smtClean="0"/>
-              <a:t>8/11/2026</a:t>
+              <a:t>8/25/2026</a:t>
             </a:fld>
             <a:endParaRPr lang="en-US"/>
           </a:p>
@@ -675,7 +675,7 @@
           <a:p>
             <a:fld id="{5BCAD085-E8A6-8845-BD4E-CB4CCA059FC4}" type="datetimeFigureOut">
               <a:rPr lang="en-US" smtClean="0"/>
-              <a:t>8/11/2026</a:t>
+              <a:t>8/25/2026</a:t>
             </a:fld>
             <a:endParaRPr lang="en-US"/>
           </a:p>
@@ -843,7 +843,7 @@
           <a:p>
             <a:fld id="{5BCAD085-E8A6-8845-BD4E-CB4CCA059FC4}" type="datetimeFigureOut">
               <a:rPr lang="en-US" smtClean="0"/>
-              <a:t>8/11/2026</a:t>
+              <a:t>8/25/2026</a:t>
             </a:fld>
             <a:endParaRPr lang="en-US"/>
           </a:p>
@@ -1088,7 +1088,7 @@
           <a:p>
             <a:fld id="{5BCAD085-E8A6-8845-BD4E-CB4CCA059FC4}" type="datetimeFigureOut">
               <a:rPr lang="en-US" smtClean="0"/>
-              <a:t>8/11/2026</a:t>
+              <a:t>8/25/2026</a:t>
             </a:fld>
             <a:endParaRPr lang="en-US"/>
           </a:p>
@@ -1373,7 +1373,7 @@
           <a:p>
             <a:fld id="{5BCAD085-E8A6-8845-BD4E-CB4CCA059FC4}" type="datetimeFigureOut">
               <a:rPr lang="en-US" smtClean="0"/>
-              <a:t>8/11/2026</a:t>
+              <a:t>8/25/2026</a:t>
             </a:fld>
             <a:endParaRPr lang="en-US"/>
           </a:p>
@@ -1792,7 +1792,7 @@
           <a:p>
             <a:fld id="{5BCAD085-E8A6-8845-BD4E-CB4CCA059FC4}" type="datetimeFigureOut">
               <a:rPr lang="en-US" smtClean="0"/>
-              <a:t>8/11/2026</a:t>
+              <a:t>8/25/2026</a:t>
             </a:fld>
             <a:endParaRPr lang="en-US"/>
           </a:p>
@@ -1909,7 +1909,7 @@
           <a:p>
             <a:fld id="{5BCAD085-E8A6-8845-BD4E-CB4CCA059FC4}" type="datetimeFigureOut">
               <a:rPr lang="en-US" smtClean="0"/>
-              <a:t>8/11/2026</a:t>
+              <a:t>8/25/2026</a:t>
             </a:fld>
             <a:endParaRPr lang="en-US"/>
           </a:p>
@@ -2004,7 +2004,7 @@
           <a:p>
             <a:fld id="{5BCAD085-E8A6-8845-BD4E-CB4CCA059FC4}" type="datetimeFigureOut">
               <a:rPr lang="en-US" smtClean="0"/>
-              <a:t>8/11/2026</a:t>
+              <a:t>8/25/2026</a:t>
             </a:fld>
             <a:endParaRPr lang="en-US"/>
           </a:p>
@@ -2279,7 +2279,7 @@
           <a:p>
             <a:fld id="{5BCAD085-E8A6-8845-BD4E-CB4CCA059FC4}" type="datetimeFigureOut">
               <a:rPr lang="en-US" smtClean="0"/>
-              <a:t>8/11/2026</a:t>
+              <a:t>8/25/2026</a:t>
             </a:fld>
             <a:endParaRPr lang="en-US"/>
           </a:p>
@@ -2531,7 +2531,7 @@
           <a:p>
             <a:fld id="{5BCAD085-E8A6-8845-BD4E-CB4CCA059FC4}" type="datetimeFigureOut">
               <a:rPr lang="en-US" smtClean="0"/>
-              <a:t>8/11/2026</a:t>
+              <a:t>8/25/2026</a:t>
             </a:fld>
             <a:endParaRPr lang="en-US"/>
           </a:p>
@@ -2742,7 +2742,7 @@
           <a:p>
             <a:fld id="{5BCAD085-E8A6-8845-BD4E-CB4CCA059FC4}" type="datetimeFigureOut">
               <a:rPr lang="en-US" smtClean="0"/>
-              <a:t>8/11/2026</a:t>
+              <a:t>8/25/2026</a:t>
             </a:fld>
             <a:endParaRPr lang="en-US"/>
           </a:p>
@@ -4173,13 +4173,82 @@
                     <a:p>
                       <a:pPr algn="l"/>
                       <a:r>
+                        <a:rPr sz="850" b="1" i="0">
+                          <a:solidFill>
+                            <a:srgbClr val="C00000"/>
+                          </a:solidFill>
+                          <a:latin typeface="Arial"/>
+                        </a:rPr>
+                        <a:t>Chase McQueen</a:t>
+                      </a:r>
+                    </a:p>
+                  </a:txBody>
+                  <a:tcPr>
+                    <a:solidFill>
+                      <a:srgbClr val="F2F2F2"/>
+                    </a:solidFill>
+                  </a:tcPr>
+                </a:tc>
+                <a:tc>
+                  <a:txBody>
+                    <a:bodyPr/>
+                    <a:lstStyle/>
+                    <a:p>
+                      <a:pPr algn="ctr"/>
+                      <a:r>
+                        <a:rPr sz="850" b="1" i="0">
+                          <a:solidFill>
+                            <a:srgbClr val="262626"/>
+                          </a:solidFill>
+                          <a:latin typeface="Arial"/>
+                        </a:rPr>
+                        <a:t>85%</a:t>
+                      </a:r>
+                    </a:p>
+                  </a:txBody>
+                  <a:tcPr>
+                    <a:solidFill>
+                      <a:srgbClr val="F2F2F2"/>
+                    </a:solidFill>
+                  </a:tcPr>
+                </a:tc>
+                <a:tc>
+                  <a:txBody>
+                    <a:bodyPr/>
+                    <a:lstStyle/>
+                    <a:p>
+                      <a:pPr algn="ctr"/>
+                      <a:r>
+                        <a:rPr sz="850" b="1" i="0">
+                          <a:solidFill>
+                            <a:srgbClr val="262626"/>
+                          </a:solidFill>
+                          <a:latin typeface="Arial"/>
+                        </a:rPr>
+                        <a:t>9:04</a:t>
+                      </a:r>
+                    </a:p>
+                  </a:txBody>
+                  <a:tcPr>
+                    <a:solidFill>
+                      <a:srgbClr val="F2F2F2"/>
+                    </a:solidFill>
+                  </a:tcPr>
+                </a:tc>
+                <a:tc>
+                  <a:txBody>
+                    <a:bodyPr/>
+                    <a:lstStyle/>
+                    <a:p>
+                      <a:pPr algn="ctr"/>
+                      <a:r>
                         <a:rPr sz="850" b="0" i="0">
                           <a:solidFill>
                             <a:srgbClr val="262626"/>
                           </a:solidFill>
                           <a:latin typeface="Arial"/>
                         </a:rPr>
-                        <a:t>Csongor Lehmann</a:t>
+                        <a:t>17:47</a:t>
                       </a:r>
                     </a:p>
                   </a:txBody>
@@ -4196,82 +4265,13 @@
                     <a:p>
                       <a:pPr algn="ctr"/>
                       <a:r>
-                        <a:rPr sz="850" b="1" i="0">
-                          <a:solidFill>
-                            <a:srgbClr val="262626"/>
-                          </a:solidFill>
-                          <a:latin typeface="Arial"/>
-                        </a:rPr>
-                        <a:t>85%</a:t>
-                      </a:r>
-                    </a:p>
-                  </a:txBody>
-                  <a:tcPr>
-                    <a:solidFill>
-                      <a:srgbClr val="F2F2F2"/>
-                    </a:solidFill>
-                  </a:tcPr>
-                </a:tc>
-                <a:tc>
-                  <a:txBody>
-                    <a:bodyPr/>
-                    <a:lstStyle/>
-                    <a:p>
-                      <a:pPr algn="ctr"/>
-                      <a:r>
-                        <a:rPr sz="850" b="1" i="0">
-                          <a:solidFill>
-                            <a:srgbClr val="262626"/>
-                          </a:solidFill>
-                          <a:latin typeface="Arial"/>
-                        </a:rPr>
-                        <a:t>8:37</a:t>
-                      </a:r>
-                    </a:p>
-                  </a:txBody>
-                  <a:tcPr>
-                    <a:solidFill>
-                      <a:srgbClr val="F2F2F2"/>
-                    </a:solidFill>
-                  </a:tcPr>
-                </a:tc>
-                <a:tc>
-                  <a:txBody>
-                    <a:bodyPr/>
-                    <a:lstStyle/>
-                    <a:p>
-                      <a:pPr algn="ctr"/>
-                      <a:r>
                         <a:rPr sz="850" b="0" i="0">
                           <a:solidFill>
-                            <a:srgbClr val="262626"/>
-                          </a:solidFill>
-                          <a:latin typeface="Arial"/>
-                        </a:rPr>
-                        <a:t>17:22</a:t>
-                      </a:r>
-                    </a:p>
-                  </a:txBody>
-                  <a:tcPr>
-                    <a:solidFill>
-                      <a:srgbClr val="F2F2F2"/>
-                    </a:solidFill>
-                  </a:tcPr>
-                </a:tc>
-                <a:tc>
-                  <a:txBody>
-                    <a:bodyPr/>
-                    <a:lstStyle/>
-                    <a:p>
-                      <a:pPr algn="ctr"/>
-                      <a:r>
-                        <a:rPr sz="850" b="0" i="0">
-                          <a:solidFill>
                             <a:srgbClr val="BFBFBF"/>
                           </a:solidFill>
                           <a:latin typeface="Arial"/>
                         </a:rPr>
-                        <a:t>5/15</a:t>
+                        <a:t>9/11</a:t>
                       </a:r>
                     </a:p>
                   </a:txBody>
@@ -4324,7 +4324,7 @@
                           </a:solidFill>
                           <a:latin typeface="Arial"/>
                         </a:rPr>
-                        <a:t>Chase McQueen</a:t>
+                        <a:t>Blake Bullard</a:t>
                       </a:r>
                     </a:p>
                   </a:txBody>
@@ -4347,7 +4347,7 @@
                           </a:solidFill>
                           <a:latin typeface="Arial"/>
                         </a:rPr>
-                        <a:t>85%</a:t>
+                        <a:t>80%</a:t>
                       </a:r>
                     </a:p>
                   </a:txBody>
@@ -4370,7 +4370,7 @@
                           </a:solidFill>
                           <a:latin typeface="Arial"/>
                         </a:rPr>
-                        <a:t>9:04</a:t>
+                        <a:t>9:51</a:t>
                       </a:r>
                     </a:p>
                   </a:txBody>
@@ -4393,7 +4393,7 @@
                           </a:solidFill>
                           <a:latin typeface="Arial"/>
                         </a:rPr>
-                        <a:t>17:47</a:t>
+                        <a:t>—</a:t>
                       </a:r>
                     </a:p>
                   </a:txBody>
@@ -4416,7 +4416,7 @@
                           </a:solidFill>
                           <a:latin typeface="Arial"/>
                         </a:rPr>
-                        <a:t>9/11</a:t>
+                        <a:t>10/0</a:t>
                       </a:r>
                     </a:p>
                   </a:txBody>
@@ -4469,7 +4469,7 @@
                           </a:solidFill>
                           <a:latin typeface="Arial"/>
                         </a:rPr>
-                        <a:t>Márton Kropkó</a:t>
+                        <a:t>Alberto Gonzalez Garcia</a:t>
                       </a:r>
                     </a:p>
                   </a:txBody>
@@ -4492,7 +4492,7 @@
                           </a:solidFill>
                           <a:latin typeface="Arial"/>
                         </a:rPr>
-                        <a:t>80%</a:t>
+                        <a:t>79%</a:t>
                       </a:r>
                     </a:p>
                   </a:txBody>
@@ -4515,7 +4515,7 @@
                           </a:solidFill>
                           <a:latin typeface="Arial"/>
                         </a:rPr>
-                        <a:t>8:56</a:t>
+                        <a:t>9:03</a:t>
                       </a:r>
                     </a:p>
                   </a:txBody>
@@ -4538,7 +4538,7 @@
                           </a:solidFill>
                           <a:latin typeface="Arial"/>
                         </a:rPr>
-                        <a:t>17:47</a:t>
+                        <a:t>18:08</a:t>
                       </a:r>
                     </a:p>
                   </a:txBody>
@@ -4561,7 +4561,7 @@
                           </a:solidFill>
                           <a:latin typeface="Arial"/>
                         </a:rPr>
-                        <a:t>2/3</a:t>
+                        <a:t>16/8</a:t>
                       </a:r>
                     </a:p>
                   </a:txBody>
@@ -4608,13 +4608,36 @@
                     <a:p>
                       <a:pPr algn="l"/>
                       <a:r>
+                        <a:rPr sz="850" b="0" i="0">
+                          <a:solidFill>
+                            <a:srgbClr val="262626"/>
+                          </a:solidFill>
+                          <a:latin typeface="Arial"/>
+                        </a:rPr>
+                        <a:t>Kenji Nener</a:t>
+                      </a:r>
+                    </a:p>
+                  </a:txBody>
+                  <a:tcPr>
+                    <a:solidFill>
+                      <a:srgbClr val="FFFFFF"/>
+                    </a:solidFill>
+                  </a:tcPr>
+                </a:tc>
+                <a:tc>
+                  <a:txBody>
+                    <a:bodyPr/>
+                    <a:lstStyle/>
+                    <a:p>
+                      <a:pPr algn="ctr"/>
+                      <a:r>
                         <a:rPr sz="850" b="1" i="0">
                           <a:solidFill>
-                            <a:srgbClr val="C00000"/>
-                          </a:solidFill>
-                          <a:latin typeface="Arial"/>
-                        </a:rPr>
-                        <a:t>Blake Bullard</a:t>
+                            <a:srgbClr val="262626"/>
+                          </a:solidFill>
+                          <a:latin typeface="Arial"/>
+                        </a:rPr>
+                        <a:t>74%</a:t>
                       </a:r>
                     </a:p>
                   </a:txBody>
@@ -4637,30 +4660,7 @@
                           </a:solidFill>
                           <a:latin typeface="Arial"/>
                         </a:rPr>
-                        <a:t>80%</a:t>
-                      </a:r>
-                    </a:p>
-                  </a:txBody>
-                  <a:tcPr>
-                    <a:solidFill>
-                      <a:srgbClr val="FFFFFF"/>
-                    </a:solidFill>
-                  </a:tcPr>
-                </a:tc>
-                <a:tc>
-                  <a:txBody>
-                    <a:bodyPr/>
-                    <a:lstStyle/>
-                    <a:p>
-                      <a:pPr algn="ctr"/>
-                      <a:r>
-                        <a:rPr sz="850" b="1" i="0">
-                          <a:solidFill>
-                            <a:srgbClr val="262626"/>
-                          </a:solidFill>
-                          <a:latin typeface="Arial"/>
-                        </a:rPr>
-                        <a:t>9:51</a:t>
+                        <a:t>8:53</a:t>
                       </a:r>
                     </a:p>
                   </a:txBody>
@@ -4683,7 +4683,7 @@
                           </a:solidFill>
                           <a:latin typeface="Arial"/>
                         </a:rPr>
-                        <a:t>—</a:t>
+                        <a:t>18:15</a:t>
                       </a:r>
                     </a:p>
                   </a:txBody>
@@ -4706,7 +4706,7 @@
                           </a:solidFill>
                           <a:latin typeface="Arial"/>
                         </a:rPr>
-                        <a:t>10/0</a:t>
+                        <a:t>10/13</a:t>
                       </a:r>
                     </a:p>
                   </a:txBody>
@@ -4759,7 +4759,7 @@
                           </a:solidFill>
                           <a:latin typeface="Arial"/>
                         </a:rPr>
-                        <a:t>Alberto Gonzalez Garcia</a:t>
+                        <a:t>Zalán Hóbor</a:t>
                       </a:r>
                     </a:p>
                   </a:txBody>
@@ -4782,7 +4782,7 @@
                           </a:solidFill>
                           <a:latin typeface="Arial"/>
                         </a:rPr>
-                        <a:t>79%</a:t>
+                        <a:t>73%</a:t>
                       </a:r>
                     </a:p>
                   </a:txBody>
@@ -4805,7 +4805,7 @@
                           </a:solidFill>
                           <a:latin typeface="Arial"/>
                         </a:rPr>
-                        <a:t>9:03</a:t>
+                        <a:t>8:54</a:t>
                       </a:r>
                     </a:p>
                   </a:txBody>
@@ -4828,7 +4828,7 @@
                           </a:solidFill>
                           <a:latin typeface="Arial"/>
                         </a:rPr>
-                        <a:t>18:08</a:t>
+                        <a:t>17:08</a:t>
                       </a:r>
                     </a:p>
                   </a:txBody>
@@ -4851,7 +4851,7 @@
                           </a:solidFill>
                           <a:latin typeface="Arial"/>
                         </a:rPr>
-                        <a:t>16/8</a:t>
+                        <a:t>9/2</a:t>
                       </a:r>
                     </a:p>
                   </a:txBody>
@@ -4904,7 +4904,7 @@
                           </a:solidFill>
                           <a:latin typeface="Arial"/>
                         </a:rPr>
-                        <a:t>Kenji Nener</a:t>
+                        <a:t>João Nuno Batista</a:t>
                       </a:r>
                     </a:p>
                   </a:txBody>
@@ -4927,7 +4927,7 @@
                           </a:solidFill>
                           <a:latin typeface="Arial"/>
                         </a:rPr>
-                        <a:t>74%</a:t>
+                        <a:t>70%</a:t>
                       </a:r>
                     </a:p>
                   </a:txBody>
@@ -4973,7 +4973,7 @@
                           </a:solidFill>
                           <a:latin typeface="Arial"/>
                         </a:rPr>
-                        <a:t>18:15</a:t>
+                        <a:t>18:05</a:t>
                       </a:r>
                     </a:p>
                   </a:txBody>
@@ -4996,7 +4996,7 @@
                           </a:solidFill>
                           <a:latin typeface="Arial"/>
                         </a:rPr>
-                        <a:t>10/13</a:t>
+                        <a:t>6/4</a:t>
                       </a:r>
                     </a:p>
                   </a:txBody>
@@ -5049,7 +5049,7 @@
                           </a:solidFill>
                           <a:latin typeface="Arial"/>
                         </a:rPr>
-                        <a:t>João Nuno Batista</a:t>
+                        <a:t>Takumi Hojo</a:t>
                       </a:r>
                     </a:p>
                   </a:txBody>
@@ -5072,7 +5072,7 @@
                           </a:solidFill>
                           <a:latin typeface="Arial"/>
                         </a:rPr>
-                        <a:t>70%</a:t>
+                        <a:t>65%</a:t>
                       </a:r>
                     </a:p>
                   </a:txBody>
@@ -5095,7 +5095,7 @@
                           </a:solidFill>
                           <a:latin typeface="Arial"/>
                         </a:rPr>
-                        <a:t>8:53</a:t>
+                        <a:t>8:57</a:t>
                       </a:r>
                     </a:p>
                   </a:txBody>
@@ -5118,7 +5118,7 @@
                           </a:solidFill>
                           <a:latin typeface="Arial"/>
                         </a:rPr>
-                        <a:t>18:05</a:t>
+                        <a:t>18:21</a:t>
                       </a:r>
                     </a:p>
                   </a:txBody>
@@ -5141,7 +5141,7 @@
                           </a:solidFill>
                           <a:latin typeface="Arial"/>
                         </a:rPr>
-                        <a:t>6/4</a:t>
+                        <a:t>17/14</a:t>
                       </a:r>
                     </a:p>
                   </a:txBody>
@@ -5194,7 +5194,7 @@
                           </a:solidFill>
                           <a:latin typeface="Arial"/>
                         </a:rPr>
-                        <a:t>Takumi Hojo</a:t>
+                        <a:t>Martin Demuth</a:t>
                       </a:r>
                     </a:p>
                   </a:txBody>
@@ -5217,7 +5217,7 @@
                           </a:solidFill>
                           <a:latin typeface="Arial"/>
                         </a:rPr>
-                        <a:t>65%</a:t>
+                        <a:t>64%</a:t>
                       </a:r>
                     </a:p>
                   </a:txBody>
@@ -5240,7 +5240,7 @@
                           </a:solidFill>
                           <a:latin typeface="Arial"/>
                         </a:rPr>
-                        <a:t>8:57</a:t>
+                        <a:t>9:07</a:t>
                       </a:r>
                     </a:p>
                   </a:txBody>
@@ -5263,7 +5263,7 @@
                           </a:solidFill>
                           <a:latin typeface="Arial"/>
                         </a:rPr>
-                        <a:t>18:21</a:t>
+                        <a:t>17:15</a:t>
                       </a:r>
                     </a:p>
                   </a:txBody>
@@ -5286,7 +5286,7 @@
                           </a:solidFill>
                           <a:latin typeface="Arial"/>
                         </a:rPr>
-                        <a:t>17/14</a:t>
+                        <a:t>16/12</a:t>
                       </a:r>
                     </a:p>
                   </a:txBody>
@@ -5339,7 +5339,7 @@
                           </a:solidFill>
                           <a:latin typeface="Arial"/>
                         </a:rPr>
-                        <a:t>Martin Demuth</a:t>
+                        <a:t>Maciej Bruzdziak</a:t>
                       </a:r>
                     </a:p>
                   </a:txBody>
@@ -5385,7 +5385,7 @@
                           </a:solidFill>
                           <a:latin typeface="Arial"/>
                         </a:rPr>
-                        <a:t>9:07</a:t>
+                        <a:t>8:55</a:t>
                       </a:r>
                     </a:p>
                   </a:txBody>
@@ -5408,7 +5408,7 @@
                           </a:solidFill>
                           <a:latin typeface="Arial"/>
                         </a:rPr>
-                        <a:t>17:15</a:t>
+                        <a:t>18:00</a:t>
                       </a:r>
                     </a:p>
                   </a:txBody>
@@ -5431,7 +5431,7 @@
                           </a:solidFill>
                           <a:latin typeface="Arial"/>
                         </a:rPr>
-                        <a:t>16/12</a:t>
+                        <a:t>7/15</a:t>
                       </a:r>
                     </a:p>
                   </a:txBody>
@@ -5484,7 +5484,7 @@
                           </a:solidFill>
                           <a:latin typeface="Arial"/>
                         </a:rPr>
-                        <a:t>Maciej Bruzdziak</a:t>
+                        <a:t>Gergely Kiss</a:t>
                       </a:r>
                     </a:p>
                   </a:txBody>
@@ -5507,7 +5507,7 @@
                           </a:solidFill>
                           <a:latin typeface="Arial"/>
                         </a:rPr>
-                        <a:t>64%</a:t>
+                        <a:t>62%</a:t>
                       </a:r>
                     </a:p>
                   </a:txBody>
@@ -5530,7 +5530,7 @@
                           </a:solidFill>
                           <a:latin typeface="Arial"/>
                         </a:rPr>
-                        <a:t>8:55</a:t>
+                        <a:t>8:53</a:t>
                       </a:r>
                     </a:p>
                   </a:txBody>
@@ -5553,7 +5553,7 @@
                           </a:solidFill>
                           <a:latin typeface="Arial"/>
                         </a:rPr>
-                        <a:t>18:00</a:t>
+                        <a:t>17:57</a:t>
                       </a:r>
                     </a:p>
                   </a:txBody>
@@ -5576,7 +5576,7 @@
                           </a:solidFill>
                           <a:latin typeface="Arial"/>
                         </a:rPr>
-                        <a:t>7/15</a:t>
+                        <a:t>10/6</a:t>
                       </a:r>
                     </a:p>
                   </a:txBody>
@@ -5629,7 +5629,7 @@
                           </a:solidFill>
                           <a:latin typeface="Arial"/>
                         </a:rPr>
-                        <a:t>Gergely Kiss</a:t>
+                        <a:t>Nicola Azzano</a:t>
                       </a:r>
                     </a:p>
                   </a:txBody>
@@ -5675,7 +5675,7 @@
                           </a:solidFill>
                           <a:latin typeface="Arial"/>
                         </a:rPr>
-                        <a:t>8:53</a:t>
+                        <a:t>8:57</a:t>
                       </a:r>
                     </a:p>
                   </a:txBody>
@@ -5698,7 +5698,7 @@
                           </a:solidFill>
                           <a:latin typeface="Arial"/>
                         </a:rPr>
-                        <a:t>17:57</a:t>
+                        <a:t>18:01</a:t>
                       </a:r>
                     </a:p>
                   </a:txBody>
@@ -5721,7 +5721,7 @@
                           </a:solidFill>
                           <a:latin typeface="Arial"/>
                         </a:rPr>
-                        <a:t>10/6</a:t>
+                        <a:t>21/13</a:t>
                       </a:r>
                     </a:p>
                   </a:txBody>
@@ -5768,59 +5768,82 @@
                     <a:p>
                       <a:pPr algn="l"/>
                       <a:r>
+                        <a:rPr sz="850" b="1" i="0">
+                          <a:solidFill>
+                            <a:srgbClr val="C00000"/>
+                          </a:solidFill>
+                          <a:latin typeface="Arial"/>
+                        </a:rPr>
+                        <a:t>Darr Smith</a:t>
+                      </a:r>
+                    </a:p>
+                  </a:txBody>
+                  <a:tcPr>
+                    <a:solidFill>
+                      <a:srgbClr val="FFFFFF"/>
+                    </a:solidFill>
+                  </a:tcPr>
+                </a:tc>
+                <a:tc>
+                  <a:txBody>
+                    <a:bodyPr/>
+                    <a:lstStyle/>
+                    <a:p>
+                      <a:pPr algn="ctr"/>
+                      <a:r>
+                        <a:rPr sz="850" b="1" i="0">
+                          <a:solidFill>
+                            <a:srgbClr val="262626"/>
+                          </a:solidFill>
+                          <a:latin typeface="Arial"/>
+                        </a:rPr>
+                        <a:t>58%</a:t>
+                      </a:r>
+                    </a:p>
+                  </a:txBody>
+                  <a:tcPr>
+                    <a:solidFill>
+                      <a:srgbClr val="FFFFFF"/>
+                    </a:solidFill>
+                  </a:tcPr>
+                </a:tc>
+                <a:tc>
+                  <a:txBody>
+                    <a:bodyPr/>
+                    <a:lstStyle/>
+                    <a:p>
+                      <a:pPr algn="ctr"/>
+                      <a:r>
+                        <a:rPr sz="850" b="1" i="0">
+                          <a:solidFill>
+                            <a:srgbClr val="262626"/>
+                          </a:solidFill>
+                          <a:latin typeface="Arial"/>
+                        </a:rPr>
+                        <a:t>9:05</a:t>
+                      </a:r>
+                    </a:p>
+                  </a:txBody>
+                  <a:tcPr>
+                    <a:solidFill>
+                      <a:srgbClr val="FFFFFF"/>
+                    </a:solidFill>
+                  </a:tcPr>
+                </a:tc>
+                <a:tc>
+                  <a:txBody>
+                    <a:bodyPr/>
+                    <a:lstStyle/>
+                    <a:p>
+                      <a:pPr algn="ctr"/>
+                      <a:r>
                         <a:rPr sz="850" b="0" i="0">
                           <a:solidFill>
                             <a:srgbClr val="262626"/>
                           </a:solidFill>
                           <a:latin typeface="Arial"/>
                         </a:rPr>
-                        <a:t>Nicola Azzano</a:t>
-                      </a:r>
-                    </a:p>
-                  </a:txBody>
-                  <a:tcPr>
-                    <a:solidFill>
-                      <a:srgbClr val="FFFFFF"/>
-                    </a:solidFill>
-                  </a:tcPr>
-                </a:tc>
-                <a:tc>
-                  <a:txBody>
-                    <a:bodyPr/>
-                    <a:lstStyle/>
-                    <a:p>
-                      <a:pPr algn="ctr"/>
-                      <a:r>
-                        <a:rPr sz="850" b="1" i="0">
-                          <a:solidFill>
-                            <a:srgbClr val="262626"/>
-                          </a:solidFill>
-                          <a:latin typeface="Arial"/>
-                        </a:rPr>
-                        <a:t>62%</a:t>
-                      </a:r>
-                    </a:p>
-                  </a:txBody>
-                  <a:tcPr>
-                    <a:solidFill>
-                      <a:srgbClr val="FFFFFF"/>
-                    </a:solidFill>
-                  </a:tcPr>
-                </a:tc>
-                <a:tc>
-                  <a:txBody>
-                    <a:bodyPr/>
-                    <a:lstStyle/>
-                    <a:p>
-                      <a:pPr algn="ctr"/>
-                      <a:r>
-                        <a:rPr sz="850" b="1" i="0">
-                          <a:solidFill>
-                            <a:srgbClr val="262626"/>
-                          </a:solidFill>
-                          <a:latin typeface="Arial"/>
-                        </a:rPr>
-                        <a:t>8:57</a:t>
+                        <a:t>18:07</a:t>
                       </a:r>
                     </a:p>
                   </a:txBody>
@@ -5839,34 +5862,11 @@
                       <a:r>
                         <a:rPr sz="850" b="0" i="0">
                           <a:solidFill>
-                            <a:srgbClr val="262626"/>
-                          </a:solidFill>
-                          <a:latin typeface="Arial"/>
-                        </a:rPr>
-                        <a:t>18:01</a:t>
-                      </a:r>
-                    </a:p>
-                  </a:txBody>
-                  <a:tcPr>
-                    <a:solidFill>
-                      <a:srgbClr val="FFFFFF"/>
-                    </a:solidFill>
-                  </a:tcPr>
-                </a:tc>
-                <a:tc>
-                  <a:txBody>
-                    <a:bodyPr/>
-                    <a:lstStyle/>
-                    <a:p>
-                      <a:pPr algn="ctr"/>
-                      <a:r>
-                        <a:rPr sz="850" b="0" i="0">
-                          <a:solidFill>
                             <a:srgbClr val="BFBFBF"/>
                           </a:solidFill>
                           <a:latin typeface="Arial"/>
                         </a:rPr>
-                        <a:t>21/13</a:t>
+                        <a:t>17/14</a:t>
                       </a:r>
                     </a:p>
                   </a:txBody>
@@ -5913,13 +5913,36 @@
                     <a:p>
                       <a:pPr algn="l"/>
                       <a:r>
+                        <a:rPr sz="850" b="0" i="0">
+                          <a:solidFill>
+                            <a:srgbClr val="262626"/>
+                          </a:solidFill>
+                          <a:latin typeface="Arial"/>
+                        </a:rPr>
+                        <a:t>Alois Knabl</a:t>
+                      </a:r>
+                    </a:p>
+                  </a:txBody>
+                  <a:tcPr>
+                    <a:solidFill>
+                      <a:srgbClr val="F2F2F2"/>
+                    </a:solidFill>
+                  </a:tcPr>
+                </a:tc>
+                <a:tc>
+                  <a:txBody>
+                    <a:bodyPr/>
+                    <a:lstStyle/>
+                    <a:p>
+                      <a:pPr algn="ctr"/>
+                      <a:r>
                         <a:rPr sz="850" b="1" i="0">
                           <a:solidFill>
-                            <a:srgbClr val="C00000"/>
-                          </a:solidFill>
-                          <a:latin typeface="Arial"/>
-                        </a:rPr>
-                        <a:t>Darr Smith</a:t>
+                            <a:srgbClr val="262626"/>
+                          </a:solidFill>
+                          <a:latin typeface="Arial"/>
+                        </a:rPr>
+                        <a:t>57%</a:t>
                       </a:r>
                     </a:p>
                   </a:txBody>
@@ -5942,7 +5965,7 @@
                           </a:solidFill>
                           <a:latin typeface="Arial"/>
                         </a:rPr>
-                        <a:t>58%</a:t>
+                        <a:t>8:59</a:t>
                       </a:r>
                     </a:p>
                   </a:txBody>
@@ -5959,13 +5982,13 @@
                     <a:p>
                       <a:pPr algn="ctr"/>
                       <a:r>
-                        <a:rPr sz="850" b="1" i="0">
-                          <a:solidFill>
-                            <a:srgbClr val="262626"/>
-                          </a:solidFill>
-                          <a:latin typeface="Arial"/>
-                        </a:rPr>
-                        <a:t>9:05</a:t>
+                        <a:rPr sz="850" b="0" i="0">
+                          <a:solidFill>
+                            <a:srgbClr val="262626"/>
+                          </a:solidFill>
+                          <a:latin typeface="Arial"/>
+                        </a:rPr>
+                        <a:t>17:10</a:t>
                       </a:r>
                     </a:p>
                   </a:txBody>
@@ -5984,34 +6007,11 @@
                       <a:r>
                         <a:rPr sz="850" b="0" i="0">
                           <a:solidFill>
-                            <a:srgbClr val="262626"/>
-                          </a:solidFill>
-                          <a:latin typeface="Arial"/>
-                        </a:rPr>
-                        <a:t>18:07</a:t>
-                      </a:r>
-                    </a:p>
-                  </a:txBody>
-                  <a:tcPr>
-                    <a:solidFill>
-                      <a:srgbClr val="F2F2F2"/>
-                    </a:solidFill>
-                  </a:tcPr>
-                </a:tc>
-                <a:tc>
-                  <a:txBody>
-                    <a:bodyPr/>
-                    <a:lstStyle/>
-                    <a:p>
-                      <a:pPr algn="ctr"/>
-                      <a:r>
-                        <a:rPr sz="850" b="0" i="0">
-                          <a:solidFill>
                             <a:srgbClr val="BFBFBF"/>
                           </a:solidFill>
                           <a:latin typeface="Arial"/>
                         </a:rPr>
-                        <a:t>17/14</a:t>
+                        <a:t>8/13</a:t>
                       </a:r>
                     </a:p>
                   </a:txBody>
@@ -6644,7 +6644,7 @@
                           </a:solidFill>
                           <a:latin typeface="Arial"/>
                         </a:rPr>
-                        <a:t>Sophie Evans</a:t>
+                        <a:t>Cassandre Beaugrand</a:t>
                       </a:r>
                     </a:p>
                   </a:txBody>
@@ -6667,7 +6667,7 @@
                           </a:solidFill>
                           <a:latin typeface="Arial"/>
                         </a:rPr>
-                        <a:t>89%</a:t>
+                        <a:t>87%</a:t>
                       </a:r>
                     </a:p>
                   </a:txBody>
@@ -6690,7 +6690,7 @@
                           </a:solidFill>
                           <a:latin typeface="Arial"/>
                         </a:rPr>
-                        <a:t>9:17</a:t>
+                        <a:t>9:50</a:t>
                       </a:r>
                     </a:p>
                   </a:txBody>
@@ -6713,7 +6713,7 @@
                           </a:solidFill>
                           <a:latin typeface="Arial"/>
                         </a:rPr>
-                        <a:t>19:22</a:t>
+                        <a:t>19:42</a:t>
                       </a:r>
                     </a:p>
                   </a:txBody>
@@ -6736,7 +6736,7 @@
                           </a:solidFill>
                           <a:latin typeface="Arial"/>
                         </a:rPr>
-                        <a:t>3/6</a:t>
+                        <a:t>5/10</a:t>
                       </a:r>
                     </a:p>
                   </a:txBody>
@@ -6789,7 +6789,7 @@
                           </a:solidFill>
                           <a:latin typeface="Arial"/>
                         </a:rPr>
-                        <a:t>Cassandre Beaugrand</a:t>
+                        <a:t>Desirae Ridenour</a:t>
                       </a:r>
                     </a:p>
                   </a:txBody>
@@ -6812,7 +6812,7 @@
                           </a:solidFill>
                           <a:latin typeface="Arial"/>
                         </a:rPr>
-                        <a:t>87%</a:t>
+                        <a:t>81%</a:t>
                       </a:r>
                     </a:p>
                   </a:txBody>
@@ -6835,7 +6835,7 @@
                           </a:solidFill>
                           <a:latin typeface="Arial"/>
                         </a:rPr>
-                        <a:t>9:50</a:t>
+                        <a:t>10:11</a:t>
                       </a:r>
                     </a:p>
                   </a:txBody>
@@ -6858,7 +6858,7 @@
                           </a:solidFill>
                           <a:latin typeface="Arial"/>
                         </a:rPr>
-                        <a:t>19:42</a:t>
+                        <a:t>19:31</a:t>
                       </a:r>
                     </a:p>
                   </a:txBody>
@@ -6881,7 +6881,7 @@
                           </a:solidFill>
                           <a:latin typeface="Arial"/>
                         </a:rPr>
-                        <a:t>5/10</a:t>
+                        <a:t>20/1</a:t>
                       </a:r>
                     </a:p>
                   </a:txBody>
@@ -6934,7 +6934,7 @@
                           </a:solidFill>
                           <a:latin typeface="Arial"/>
                         </a:rPr>
-                        <a:t>Desirae Ridenour</a:t>
+                        <a:t>Yuan Yuan</a:t>
                       </a:r>
                     </a:p>
                   </a:txBody>
@@ -6957,7 +6957,7 @@
                           </a:solidFill>
                           <a:latin typeface="Arial"/>
                         </a:rPr>
-                        <a:t>81%</a:t>
+                        <a:t>80%</a:t>
                       </a:r>
                     </a:p>
                   </a:txBody>
@@ -6980,7 +6980,7 @@
                           </a:solidFill>
                           <a:latin typeface="Arial"/>
                         </a:rPr>
-                        <a:t>10:11</a:t>
+                        <a:t>9:56</a:t>
                       </a:r>
                     </a:p>
                   </a:txBody>
@@ -7003,7 +7003,7 @@
                           </a:solidFill>
                           <a:latin typeface="Arial"/>
                         </a:rPr>
-                        <a:t>19:31</a:t>
+                        <a:t>20:17</a:t>
                       </a:r>
                     </a:p>
                   </a:txBody>
@@ -7026,7 +7026,7 @@
                           </a:solidFill>
                           <a:latin typeface="Arial"/>
                         </a:rPr>
-                        <a:t>20/1</a:t>
+                        <a:t>2/8</a:t>
                       </a:r>
                     </a:p>
                   </a:txBody>
@@ -7073,13 +7073,82 @@
                     <a:p>
                       <a:pPr algn="l"/>
                       <a:r>
+                        <a:rPr sz="850" b="1" i="0">
+                          <a:solidFill>
+                            <a:srgbClr val="C00000"/>
+                          </a:solidFill>
+                          <a:latin typeface="Arial"/>
+                        </a:rPr>
+                        <a:t>Kirsten Kasper</a:t>
+                      </a:r>
+                    </a:p>
+                  </a:txBody>
+                  <a:tcPr>
+                    <a:solidFill>
+                      <a:srgbClr val="F2F2F2"/>
+                    </a:solidFill>
+                  </a:tcPr>
+                </a:tc>
+                <a:tc>
+                  <a:txBody>
+                    <a:bodyPr/>
+                    <a:lstStyle/>
+                    <a:p>
+                      <a:pPr algn="ctr"/>
+                      <a:r>
+                        <a:rPr sz="850" b="1" i="0">
+                          <a:solidFill>
+                            <a:srgbClr val="262626"/>
+                          </a:solidFill>
+                          <a:latin typeface="Arial"/>
+                        </a:rPr>
+                        <a:t>62%</a:t>
+                      </a:r>
+                    </a:p>
+                  </a:txBody>
+                  <a:tcPr>
+                    <a:solidFill>
+                      <a:srgbClr val="F2F2F2"/>
+                    </a:solidFill>
+                  </a:tcPr>
+                </a:tc>
+                <a:tc>
+                  <a:txBody>
+                    <a:bodyPr/>
+                    <a:lstStyle/>
+                    <a:p>
+                      <a:pPr algn="ctr"/>
+                      <a:r>
+                        <a:rPr sz="850" b="1" i="0">
+                          <a:solidFill>
+                            <a:srgbClr val="262626"/>
+                          </a:solidFill>
+                          <a:latin typeface="Arial"/>
+                        </a:rPr>
+                        <a:t>10:06</a:t>
+                      </a:r>
+                    </a:p>
+                  </a:txBody>
+                  <a:tcPr>
+                    <a:solidFill>
+                      <a:srgbClr val="F2F2F2"/>
+                    </a:solidFill>
+                  </a:tcPr>
+                </a:tc>
+                <a:tc>
+                  <a:txBody>
+                    <a:bodyPr/>
+                    <a:lstStyle/>
+                    <a:p>
+                      <a:pPr algn="ctr"/>
+                      <a:r>
                         <a:rPr sz="850" b="0" i="0">
                           <a:solidFill>
                             <a:srgbClr val="262626"/>
                           </a:solidFill>
                           <a:latin typeface="Arial"/>
                         </a:rPr>
-                        <a:t>Erin McConnell</a:t>
+                        <a:t>20:03</a:t>
                       </a:r>
                     </a:p>
                   </a:txBody>
@@ -7096,82 +7165,13 @@
                     <a:p>
                       <a:pPr algn="ctr"/>
                       <a:r>
-                        <a:rPr sz="850" b="1" i="0">
-                          <a:solidFill>
-                            <a:srgbClr val="262626"/>
-                          </a:solidFill>
-                          <a:latin typeface="Arial"/>
-                        </a:rPr>
-                        <a:t>77%</a:t>
-                      </a:r>
-                    </a:p>
-                  </a:txBody>
-                  <a:tcPr>
-                    <a:solidFill>
-                      <a:srgbClr val="F2F2F2"/>
-                    </a:solidFill>
-                  </a:tcPr>
-                </a:tc>
-                <a:tc>
-                  <a:txBody>
-                    <a:bodyPr/>
-                    <a:lstStyle/>
-                    <a:p>
-                      <a:pPr algn="ctr"/>
-                      <a:r>
-                        <a:rPr sz="850" b="1" i="0">
-                          <a:solidFill>
-                            <a:srgbClr val="262626"/>
-                          </a:solidFill>
-                          <a:latin typeface="Arial"/>
-                        </a:rPr>
-                        <a:t>9:28</a:t>
-                      </a:r>
-                    </a:p>
-                  </a:txBody>
-                  <a:tcPr>
-                    <a:solidFill>
-                      <a:srgbClr val="F2F2F2"/>
-                    </a:solidFill>
-                  </a:tcPr>
-                </a:tc>
-                <a:tc>
-                  <a:txBody>
-                    <a:bodyPr/>
-                    <a:lstStyle/>
-                    <a:p>
-                      <a:pPr algn="ctr"/>
-                      <a:r>
                         <a:rPr sz="850" b="0" i="0">
                           <a:solidFill>
-                            <a:srgbClr val="262626"/>
-                          </a:solidFill>
-                          <a:latin typeface="Arial"/>
-                        </a:rPr>
-                        <a:t>—</a:t>
-                      </a:r>
-                    </a:p>
-                  </a:txBody>
-                  <a:tcPr>
-                    <a:solidFill>
-                      <a:srgbClr val="F2F2F2"/>
-                    </a:solidFill>
-                  </a:tcPr>
-                </a:tc>
-                <a:tc>
-                  <a:txBody>
-                    <a:bodyPr/>
-                    <a:lstStyle/>
-                    <a:p>
-                      <a:pPr algn="ctr"/>
-                      <a:r>
-                        <a:rPr sz="850" b="0" i="0">
-                          <a:solidFill>
                             <a:srgbClr val="BFBFBF"/>
                           </a:solidFill>
                           <a:latin typeface="Arial"/>
                         </a:rPr>
-                        <a:t>13/0</a:t>
+                        <a:t>6/10</a:t>
                       </a:r>
                     </a:p>
                   </a:txBody>
@@ -7224,7 +7224,7 @@
                           </a:solidFill>
                           <a:latin typeface="Arial"/>
                         </a:rPr>
-                        <a:t>Sophia Howell</a:t>
+                        <a:t>Beth Potter</a:t>
                       </a:r>
                     </a:p>
                   </a:txBody>
@@ -7247,7 +7247,7 @@
                           </a:solidFill>
                           <a:latin typeface="Arial"/>
                         </a:rPr>
-                        <a:t>75%</a:t>
+                        <a:t>61%</a:t>
                       </a:r>
                     </a:p>
                   </a:txBody>
@@ -7270,7 +7270,7 @@
                           </a:solidFill>
                           <a:latin typeface="Arial"/>
                         </a:rPr>
-                        <a:t>9:44</a:t>
+                        <a:t>9:56</a:t>
                       </a:r>
                     </a:p>
                   </a:txBody>
@@ -7293,7 +7293,7 @@
                           </a:solidFill>
                           <a:latin typeface="Arial"/>
                         </a:rPr>
-                        <a:t>19:46</a:t>
+                        <a:t>19:08</a:t>
                       </a:r>
                     </a:p>
                   </a:txBody>
@@ -7316,7 +7316,7 @@
                           </a:solidFill>
                           <a:latin typeface="Arial"/>
                         </a:rPr>
-                        <a:t>24/8</a:t>
+                        <a:t>5/13</a:t>
                       </a:r>
                     </a:p>
                   </a:txBody>
@@ -7369,7 +7369,7 @@
                           </a:solidFill>
                           <a:latin typeface="Arial"/>
                         </a:rPr>
-                        <a:t>Márta Kropkó</a:t>
+                        <a:t>Rosa Elena Martinez Melchior</a:t>
                       </a:r>
                     </a:p>
                   </a:txBody>
@@ -7392,7 +7392,7 @@
                           </a:solidFill>
                           <a:latin typeface="Arial"/>
                         </a:rPr>
-                        <a:t>71%</a:t>
+                        <a:t>61%</a:t>
                       </a:r>
                     </a:p>
                   </a:txBody>
@@ -7415,7 +7415,7 @@
                           </a:solidFill>
                           <a:latin typeface="Arial"/>
                         </a:rPr>
-                        <a:t>9:38</a:t>
+                        <a:t>10:08</a:t>
                       </a:r>
                     </a:p>
                   </a:txBody>
@@ -7438,7 +7438,7 @@
                           </a:solidFill>
                           <a:latin typeface="Arial"/>
                         </a:rPr>
-                        <a:t>18:59</a:t>
+                        <a:t>20:33</a:t>
                       </a:r>
                     </a:p>
                   </a:txBody>
@@ -7461,7 +7461,7 @@
                           </a:solidFill>
                           <a:latin typeface="Arial"/>
                         </a:rPr>
-                        <a:t>12/9</a:t>
+                        <a:t>17/11</a:t>
                       </a:r>
                     </a:p>
                   </a:txBody>
@@ -7514,7 +7514,7 @@
                           </a:solidFill>
                           <a:latin typeface="Arial"/>
                         </a:rPr>
-                        <a:t>Sian Rainsley</a:t>
+                        <a:t>Kanae Takenaka</a:t>
                       </a:r>
                     </a:p>
                   </a:txBody>
@@ -7537,7 +7537,7 @@
                           </a:solidFill>
                           <a:latin typeface="Arial"/>
                         </a:rPr>
-                        <a:t>71%</a:t>
+                        <a:t>56%</a:t>
                       </a:r>
                     </a:p>
                   </a:txBody>
@@ -7560,7 +7560,7 @@
                           </a:solidFill>
                           <a:latin typeface="Arial"/>
                         </a:rPr>
-                        <a:t>9:45</a:t>
+                        <a:t>10:04</a:t>
                       </a:r>
                     </a:p>
                   </a:txBody>
@@ -7583,7 +7583,7 @@
                           </a:solidFill>
                           <a:latin typeface="Arial"/>
                         </a:rPr>
-                        <a:t>18:46</a:t>
+                        <a:t>19:50</a:t>
                       </a:r>
                     </a:p>
                   </a:txBody>
@@ -7606,7 +7606,7 @@
                           </a:solidFill>
                           <a:latin typeface="Arial"/>
                         </a:rPr>
-                        <a:t>8/9</a:t>
+                        <a:t>10/6</a:t>
                       </a:r>
                     </a:p>
                   </a:txBody>
@@ -7659,7 +7659,7 @@
                           </a:solidFill>
                           <a:latin typeface="Arial"/>
                         </a:rPr>
-                        <a:t>Kate Waugh</a:t>
+                        <a:t>Selina Klamt</a:t>
                       </a:r>
                     </a:p>
                   </a:txBody>
@@ -7682,7 +7682,7 @@
                           </a:solidFill>
                           <a:latin typeface="Arial"/>
                         </a:rPr>
-                        <a:t>62%</a:t>
+                        <a:t>52%</a:t>
                       </a:r>
                     </a:p>
                   </a:txBody>
@@ -7705,7 +7705,7 @@
                           </a:solidFill>
                           <a:latin typeface="Arial"/>
                         </a:rPr>
-                        <a:t>9:43</a:t>
+                        <a:t>9:44</a:t>
                       </a:r>
                     </a:p>
                   </a:txBody>
@@ -7728,7 +7728,7 @@
                           </a:solidFill>
                           <a:latin typeface="Arial"/>
                         </a:rPr>
-                        <a:t>20:29</a:t>
+                        <a:t>19:54</a:t>
                       </a:r>
                     </a:p>
                   </a:txBody>
@@ -7751,7 +7751,7 @@
                           </a:solidFill>
                           <a:latin typeface="Arial"/>
                         </a:rPr>
-                        <a:t>7/9</a:t>
+                        <a:t>10/11</a:t>
                       </a:r>
                     </a:p>
                   </a:txBody>
@@ -7798,13 +7798,36 @@
                     <a:p>
                       <a:pPr algn="l"/>
                       <a:r>
+                        <a:rPr sz="850" b="0" i="0">
+                          <a:solidFill>
+                            <a:srgbClr val="262626"/>
+                          </a:solidFill>
+                          <a:latin typeface="Arial"/>
+                        </a:rPr>
+                        <a:t>Lisa Tertsch</a:t>
+                      </a:r>
+                    </a:p>
+                  </a:txBody>
+                  <a:tcPr>
+                    <a:solidFill>
+                      <a:srgbClr val="FFFFFF"/>
+                    </a:solidFill>
+                  </a:tcPr>
+                </a:tc>
+                <a:tc>
+                  <a:txBody>
+                    <a:bodyPr/>
+                    <a:lstStyle/>
+                    <a:p>
+                      <a:pPr algn="ctr"/>
+                      <a:r>
                         <a:rPr sz="850" b="1" i="0">
                           <a:solidFill>
-                            <a:srgbClr val="C00000"/>
-                          </a:solidFill>
-                          <a:latin typeface="Arial"/>
-                        </a:rPr>
-                        <a:t>Kirsten Kasper</a:t>
+                            <a:srgbClr val="262626"/>
+                          </a:solidFill>
+                          <a:latin typeface="Arial"/>
+                        </a:rPr>
+                        <a:t>52%</a:t>
                       </a:r>
                     </a:p>
                   </a:txBody>
@@ -7827,30 +7850,7 @@
                           </a:solidFill>
                           <a:latin typeface="Arial"/>
                         </a:rPr>
-                        <a:t>62%</a:t>
-                      </a:r>
-                    </a:p>
-                  </a:txBody>
-                  <a:tcPr>
-                    <a:solidFill>
-                      <a:srgbClr val="FFFFFF"/>
-                    </a:solidFill>
-                  </a:tcPr>
-                </a:tc>
-                <a:tc>
-                  <a:txBody>
-                    <a:bodyPr/>
-                    <a:lstStyle/>
-                    <a:p>
-                      <a:pPr algn="ctr"/>
-                      <a:r>
-                        <a:rPr sz="850" b="1" i="0">
-                          <a:solidFill>
-                            <a:srgbClr val="262626"/>
-                          </a:solidFill>
-                          <a:latin typeface="Arial"/>
-                        </a:rPr>
-                        <a:t>10:06</a:t>
+                        <a:t>9:41</a:t>
                       </a:r>
                     </a:p>
                   </a:txBody>
@@ -7873,7 +7873,7 @@
                           </a:solidFill>
                           <a:latin typeface="Arial"/>
                         </a:rPr>
-                        <a:t>20:03</a:t>
+                        <a:t>19:04</a:t>
                       </a:r>
                     </a:p>
                   </a:txBody>
@@ -7896,7 +7896,7 @@
                           </a:solidFill>
                           <a:latin typeface="Arial"/>
                         </a:rPr>
-                        <a:t>6/10</a:t>
+                        <a:t>10/19</a:t>
                       </a:r>
                     </a:p>
                   </a:txBody>
@@ -7949,7 +7949,7 @@
                           </a:solidFill>
                           <a:latin typeface="Arial"/>
                         </a:rPr>
-                        <a:t>Beth Potter</a:t>
+                        <a:t>Roksana Slupek</a:t>
                       </a:r>
                     </a:p>
                   </a:txBody>
@@ -7972,7 +7972,7 @@
                           </a:solidFill>
                           <a:latin typeface="Arial"/>
                         </a:rPr>
-                        <a:t>61%</a:t>
+                        <a:t>48%</a:t>
                       </a:r>
                     </a:p>
                   </a:txBody>
@@ -7995,7 +7995,7 @@
                           </a:solidFill>
                           <a:latin typeface="Arial"/>
                         </a:rPr>
-                        <a:t>9:56</a:t>
+                        <a:t>9:59</a:t>
                       </a:r>
                     </a:p>
                   </a:txBody>
@@ -8018,7 +8018,7 @@
                           </a:solidFill>
                           <a:latin typeface="Arial"/>
                         </a:rPr>
-                        <a:t>19:08</a:t>
+                        <a:t>19:39</a:t>
                       </a:r>
                     </a:p>
                   </a:txBody>
@@ -8041,7 +8041,7 @@
                           </a:solidFill>
                           <a:latin typeface="Arial"/>
                         </a:rPr>
-                        <a:t>5/13</a:t>
+                        <a:t>7/14</a:t>
                       </a:r>
                     </a:p>
                   </a:txBody>
@@ -8094,7 +8094,7 @@
                           </a:solidFill>
                           <a:latin typeface="Arial"/>
                         </a:rPr>
-                        <a:t>Rosa Elena Martinez Melchior</a:t>
+                        <a:t>Sara Guerrero Manso</a:t>
                       </a:r>
                     </a:p>
                   </a:txBody>
@@ -8117,7 +8117,7 @@
                           </a:solidFill>
                           <a:latin typeface="Arial"/>
                         </a:rPr>
-                        <a:t>61%</a:t>
+                        <a:t>44%</a:t>
                       </a:r>
                     </a:p>
                   </a:txBody>
@@ -8140,7 +8140,7 @@
                           </a:solidFill>
                           <a:latin typeface="Arial"/>
                         </a:rPr>
-                        <a:t>10:08</a:t>
+                        <a:t>10:09</a:t>
                       </a:r>
                     </a:p>
                   </a:txBody>
@@ -8163,7 +8163,7 @@
                           </a:solidFill>
                           <a:latin typeface="Arial"/>
                         </a:rPr>
-                        <a:t>20:33</a:t>
+                        <a:t>19:39</a:t>
                       </a:r>
                     </a:p>
                   </a:txBody>
@@ -8186,7 +8186,7 @@
                           </a:solidFill>
                           <a:latin typeface="Arial"/>
                         </a:rPr>
-                        <a:t>17/11</a:t>
+                        <a:t>19/8</a:t>
                       </a:r>
                     </a:p>
                   </a:txBody>
@@ -8239,7 +8239,7 @@
                           </a:solidFill>
                           <a:latin typeface="Arial"/>
                         </a:rPr>
-                        <a:t>Kanae Takenaka</a:t>
+                        <a:t>Manami Hayashi</a:t>
                       </a:r>
                     </a:p>
                   </a:txBody>
@@ -8262,7 +8262,7 @@
                           </a:solidFill>
                           <a:latin typeface="Arial"/>
                         </a:rPr>
-                        <a:t>56%</a:t>
+                        <a:t>42%</a:t>
                       </a:r>
                     </a:p>
                   </a:txBody>
@@ -8285,7 +8285,7 @@
                           </a:solidFill>
                           <a:latin typeface="Arial"/>
                         </a:rPr>
-                        <a:t>10:04</a:t>
+                        <a:t>9:56</a:t>
                       </a:r>
                     </a:p>
                   </a:txBody>
@@ -8308,7 +8308,7 @@
                           </a:solidFill>
                           <a:latin typeface="Arial"/>
                         </a:rPr>
-                        <a:t>19:50</a:t>
+                        <a:t>20:06</a:t>
                       </a:r>
                     </a:p>
                   </a:txBody>
@@ -8331,7 +8331,7 @@
                           </a:solidFill>
                           <a:latin typeface="Arial"/>
                         </a:rPr>
-                        <a:t>10/6</a:t>
+                        <a:t>17/7</a:t>
                       </a:r>
                     </a:p>
                   </a:txBody>
@@ -8679,7 +8679,7 @@
                 </a:solidFill>
                 <a:latin typeface="Arial"/>
               </a:rPr>
-              <a:t>As of 2026-08-10   •   World Triathlon Rankings   •   Heading into Weihai   •   Race tier: WTCS</a:t>
+              <a:t>As of 2026-08-24   •   World Triathlon Rankings   •   Heading into Weihai   •   Race tier: WTCS</a:t>
             </a:r>
           </a:p>
         </p:txBody>
@@ -10224,7 +10224,7 @@
                           </a:solidFill>
                           <a:latin typeface="Arial"/>
                         </a:rPr>
-                        <a:t>52</a:t>
+                        <a:t>50</a:t>
                       </a:r>
                     </a:p>
                   </a:txBody>
@@ -10247,7 +10247,7 @@
                           </a:solidFill>
                           <a:latin typeface="Arial"/>
                         </a:rPr>
-                        <a:t>Seth Rider</a:t>
+                        <a:t>Sullivan Middaugh</a:t>
                       </a:r>
                     </a:p>
                   </a:txBody>
@@ -10270,7 +10270,7 @@
                           </a:solidFill>
                           <a:latin typeface="Arial"/>
                         </a:rPr>
-                        <a:t>2,243</a:t>
+                        <a:t>2,281</a:t>
                       </a:r>
                     </a:p>
                   </a:txBody>
@@ -10316,7 +10316,7 @@
                           </a:solidFill>
                           <a:latin typeface="Arial"/>
                         </a:rPr>
-                        <a:t>4</a:t>
+                        <a:t>6</a:t>
                       </a:r>
                     </a:p>
                   </a:txBody>
@@ -10369,7 +10369,7 @@
                           </a:solidFill>
                           <a:latin typeface="Arial"/>
                         </a:rPr>
-                        <a:t>Sullivan Middaugh</a:t>
+                        <a:t>Seth Rider</a:t>
                       </a:r>
                     </a:p>
                   </a:txBody>
@@ -10392,7 +10392,7 @@
                           </a:solidFill>
                           <a:latin typeface="Arial"/>
                         </a:rPr>
-                        <a:t>2,233</a:t>
+                        <a:t>2,243</a:t>
                       </a:r>
                     </a:p>
                   </a:txBody>
@@ -10438,7 +10438,7 @@
                           </a:solidFill>
                           <a:latin typeface="Arial"/>
                         </a:rPr>
-                        <a:t>6</a:t>
+                        <a:t>4</a:t>
                       </a:r>
                     </a:p>
                   </a:txBody>
@@ -10468,7 +10468,7 @@
                           </a:solidFill>
                           <a:latin typeface="Arial"/>
                         </a:rPr>
-                        <a:t>72</a:t>
+                        <a:t>67</a:t>
                       </a:r>
                     </a:p>
                   </a:txBody>
@@ -10514,7 +10514,7 @@
                           </a:solidFill>
                           <a:latin typeface="Arial"/>
                         </a:rPr>
-                        <a:t>1,812</a:t>
+                        <a:t>1,988</a:t>
                       </a:r>
                     </a:p>
                   </a:txBody>
@@ -10590,7 +10590,7 @@
                           </a:solidFill>
                           <a:latin typeface="Arial"/>
                         </a:rPr>
-                        <a:t>77</a:t>
+                        <a:t>80</a:t>
                       </a:r>
                     </a:p>
                   </a:txBody>
@@ -10712,7 +10712,7 @@
                           </a:solidFill>
                           <a:latin typeface="Arial"/>
                         </a:rPr>
-                        <a:t>81</a:t>
+                        <a:t>84</a:t>
                       </a:r>
                     </a:p>
                   </a:txBody>
@@ -10834,7 +10834,7 @@
                           </a:solidFill>
                           <a:latin typeface="Arial"/>
                         </a:rPr>
-                        <a:t>106</a:t>
+                        <a:t>108</a:t>
                       </a:r>
                     </a:p>
                   </a:txBody>
@@ -10956,7 +10956,7 @@
                           </a:solidFill>
                           <a:latin typeface="Arial"/>
                         </a:rPr>
-                        <a:t>112</a:t>
+                        <a:t>113</a:t>
                       </a:r>
                     </a:p>
                   </a:txBody>
@@ -11078,7 +11078,7 @@
                           </a:solidFill>
                           <a:latin typeface="Arial"/>
                         </a:rPr>
-                        <a:t>115</a:t>
+                        <a:t>116</a:t>
                       </a:r>
                     </a:p>
                   </a:txBody>
@@ -11200,7 +11200,7 @@
                           </a:solidFill>
                           <a:latin typeface="Arial"/>
                         </a:rPr>
-                        <a:t>177</a:t>
+                        <a:t>137</a:t>
                       </a:r>
                     </a:p>
                   </a:txBody>
@@ -11246,7 +11246,7 @@
                           </a:solidFill>
                           <a:latin typeface="Arial"/>
                         </a:rPr>
-                        <a:t>1,025</a:t>
+                        <a:t>1,274</a:t>
                       </a:r>
                     </a:p>
                   </a:txBody>
@@ -11322,7 +11322,7 @@
                           </a:solidFill>
                           <a:latin typeface="Arial"/>
                         </a:rPr>
-                        <a:t>281</a:t>
+                        <a:t>284</a:t>
                       </a:r>
                     </a:p>
                   </a:txBody>
@@ -11444,7 +11444,7 @@
                           </a:solidFill>
                           <a:latin typeface="Arial"/>
                         </a:rPr>
-                        <a:t>361</a:t>
+                        <a:t>350</a:t>
                       </a:r>
                     </a:p>
                   </a:txBody>
@@ -11467,7 +11467,7 @@
                           </a:solidFill>
                           <a:latin typeface="Arial"/>
                         </a:rPr>
-                        <a:t>Isaac Lamprecht</a:t>
+                        <a:t>Foster Wilfong</a:t>
                       </a:r>
                     </a:p>
                   </a:txBody>
@@ -11490,7 +11490,7 @@
                           </a:solidFill>
                           <a:latin typeface="Arial"/>
                         </a:rPr>
-                        <a:t>417</a:t>
+                        <a:t>448</a:t>
                       </a:r>
                     </a:p>
                   </a:txBody>
@@ -11513,7 +11513,7 @@
                           </a:solidFill>
                           <a:latin typeface="Arial"/>
                         </a:rPr>
-                        <a:t>6</a:t>
+                        <a:t>4</a:t>
                       </a:r>
                     </a:p>
                   </a:txBody>
@@ -11536,7 +11536,7 @@
                           </a:solidFill>
                           <a:latin typeface="Arial"/>
                         </a:rPr>
-                        <a:t>2</a:t>
+                        <a:t>—</a:t>
                       </a:r>
                     </a:p>
                   </a:txBody>
@@ -12093,7 +12093,7 @@
                           </a:solidFill>
                           <a:latin typeface="Arial"/>
                         </a:rPr>
-                        <a:t>Gwen Jorgensen</a:t>
+                        <a:t>Danielle Orie</a:t>
                       </a:r>
                     </a:p>
                   </a:txBody>
@@ -12116,7 +12116,7 @@
                           </a:solidFill>
                           <a:latin typeface="Arial"/>
                         </a:rPr>
-                        <a:t>2,700</a:t>
+                        <a:t>2,717</a:t>
                       </a:r>
                     </a:p>
                   </a:txBody>
@@ -12192,7 +12192,7 @@
                           </a:solidFill>
                           <a:latin typeface="Arial"/>
                         </a:rPr>
-                        <a:t>37</a:t>
+                        <a:t>27</a:t>
                       </a:r>
                     </a:p>
                   </a:txBody>
@@ -12215,7 +12215,7 @@
                           </a:solidFill>
                           <a:latin typeface="Arial"/>
                         </a:rPr>
-                        <a:t>Danielle Orie</a:t>
+                        <a:t>Gwen Jorgensen</a:t>
                       </a:r>
                     </a:p>
                   </a:txBody>
@@ -12238,7 +12238,7 @@
                           </a:solidFill>
                           <a:latin typeface="Arial"/>
                         </a:rPr>
-                        <a:t>2,407</a:t>
+                        <a:t>2,700</a:t>
                       </a:r>
                     </a:p>
                   </a:txBody>
@@ -12314,7 +12314,7 @@
                           </a:solidFill>
                           <a:latin typeface="Arial"/>
                         </a:rPr>
-                        <a:t>40</a:t>
+                        <a:t>42</a:t>
                       </a:r>
                     </a:p>
                   </a:txBody>
@@ -12436,7 +12436,7 @@
                           </a:solidFill>
                           <a:latin typeface="Arial"/>
                         </a:rPr>
-                        <a:t>45</a:t>
+                        <a:t>46</a:t>
                       </a:r>
                     </a:p>
                   </a:txBody>
@@ -12802,7 +12802,7 @@
                           </a:solidFill>
                           <a:latin typeface="Arial"/>
                         </a:rPr>
-                        <a:t>86</a:t>
+                        <a:t>90</a:t>
                       </a:r>
                     </a:p>
                   </a:txBody>
@@ -12924,7 +12924,7 @@
                           </a:solidFill>
                           <a:latin typeface="Arial"/>
                         </a:rPr>
-                        <a:t>92</a:t>
+                        <a:t>94</a:t>
                       </a:r>
                     </a:p>
                   </a:txBody>
@@ -13046,7 +13046,7 @@
                           </a:solidFill>
                           <a:latin typeface="Arial"/>
                         </a:rPr>
-                        <a:t>100</a:t>
+                        <a:t>101</a:t>
                       </a:r>
                     </a:p>
                   </a:txBody>
@@ -13168,7 +13168,7 @@
                           </a:solidFill>
                           <a:latin typeface="Arial"/>
                         </a:rPr>
-                        <a:t>112</a:t>
+                        <a:t>113</a:t>
                       </a:r>
                     </a:p>
                   </a:txBody>
@@ -13290,7 +13290,7 @@
                           </a:solidFill>
                           <a:latin typeface="Arial"/>
                         </a:rPr>
-                        <a:t>128</a:t>
+                        <a:t>131</a:t>
                       </a:r>
                     </a:p>
                   </a:txBody>
@@ -13412,7 +13412,7 @@
                           </a:solidFill>
                           <a:latin typeface="Arial"/>
                         </a:rPr>
-                        <a:t>161</a:t>
+                        <a:t>144</a:t>
                       </a:r>
                     </a:p>
                   </a:txBody>
@@ -13435,7 +13435,7 @@
                           </a:solidFill>
                           <a:latin typeface="Arial"/>
                         </a:rPr>
-                        <a:t>Katie McCune</a:t>
+                        <a:t>Faith Duncan</a:t>
                       </a:r>
                     </a:p>
                   </a:txBody>
@@ -13458,7 +13458,7 @@
                           </a:solidFill>
                           <a:latin typeface="Arial"/>
                         </a:rPr>
-                        <a:t>1,042</a:t>
+                        <a:t>1,156</a:t>
                       </a:r>
                     </a:p>
                   </a:txBody>
@@ -13504,7 +13504,7 @@
                           </a:solidFill>
                           <a:latin typeface="Arial"/>
                         </a:rPr>
-                        <a:t>1</a:t>
+                        <a:t>—</a:t>
                       </a:r>
                     </a:p>
                   </a:txBody>
@@ -13534,7 +13534,7 @@
                           </a:solidFill>
                           <a:latin typeface="Arial"/>
                         </a:rPr>
-                        <a:t>174</a:t>
+                        <a:t>163</a:t>
                       </a:r>
                     </a:p>
                   </a:txBody>
@@ -13557,7 +13557,7 @@
                           </a:solidFill>
                           <a:latin typeface="Arial"/>
                         </a:rPr>
-                        <a:t>Faith Duncan</a:t>
+                        <a:t>Katie McCune</a:t>
                       </a:r>
                     </a:p>
                   </a:txBody>
@@ -13580,7 +13580,7 @@
                           </a:solidFill>
                           <a:latin typeface="Arial"/>
                         </a:rPr>
-                        <a:t>940</a:t>
+                        <a:t>1,042</a:t>
                       </a:r>
                     </a:p>
                   </a:txBody>
@@ -13626,7 +13626,7 @@
                           </a:solidFill>
                           <a:latin typeface="Arial"/>
                         </a:rPr>
-                        <a:t>—</a:t>
+                        <a:t>1</a:t>
                       </a:r>
                     </a:p>
                   </a:txBody>
@@ -14101,14 +14101,14 @@
           <p:nvPr>
             <p:extLst>
               <p:ext uri="{D42A27DB-BD31-4B8C-83A1-F6EECF244321}">
-                <p14:modId xmlns:p14="http://schemas.microsoft.com/office/powerpoint/2010/main" val="3605327460"/>
+                <p14:modId xmlns:p14="http://schemas.microsoft.com/office/powerpoint/2010/main" val="691338193"/>
               </p:ext>
             </p:extLst>
           </p:nvPr>
         </p:nvGraphicFramePr>
         <p:xfrm>
-          <a:off x="274320" y="2196388"/>
-          <a:ext cx="11640309" cy="1072593"/>
+          <a:off x="216118" y="2196388"/>
+          <a:ext cx="11756712" cy="1110693"/>
         </p:xfrm>
         <a:graphic>
           <a:graphicData uri="http://schemas.openxmlformats.org/drawingml/2006/table">
@@ -14117,35 +14117,35 @@
                 <a:tableStyleId>{5C22544A-7EE6-4342-B048-85BDC9FD1C3A}</a:tableStyleId>
               </a:tblPr>
               <a:tblGrid>
-                <a:gridCol w="4399178">
+                <a:gridCol w="4443170">
                   <a:extLst>
                     <a:ext uri="{9D8B030D-6E8A-4147-A177-3AD203B41FA5}">
                       <a16:colId xmlns:a16="http://schemas.microsoft.com/office/drawing/2014/main" val="20000"/>
                     </a:ext>
                   </a:extLst>
                 </a:gridCol>
-                <a:gridCol w="1375257">
+                <a:gridCol w="1389010">
                   <a:extLst>
                     <a:ext uri="{9D8B030D-6E8A-4147-A177-3AD203B41FA5}">
                       <a16:colId xmlns:a16="http://schemas.microsoft.com/office/drawing/2014/main" val="20001"/>
                     </a:ext>
                   </a:extLst>
                 </a:gridCol>
-                <a:gridCol w="2200046">
+                <a:gridCol w="2222046">
                   <a:extLst>
                     <a:ext uri="{9D8B030D-6E8A-4147-A177-3AD203B41FA5}">
                       <a16:colId xmlns:a16="http://schemas.microsoft.com/office/drawing/2014/main" val="20002"/>
                     </a:ext>
                   </a:extLst>
                 </a:gridCol>
-                <a:gridCol w="2749600">
+                <a:gridCol w="2777096">
                   <a:extLst>
                     <a:ext uri="{9D8B030D-6E8A-4147-A177-3AD203B41FA5}">
                       <a16:colId xmlns:a16="http://schemas.microsoft.com/office/drawing/2014/main" val="20003"/>
                     </a:ext>
                   </a:extLst>
                 </a:gridCol>
-                <a:gridCol w="916228">
+                <a:gridCol w="925390">
                   <a:extLst>
                     <a:ext uri="{9D8B030D-6E8A-4147-A177-3AD203B41FA5}">
                       <a16:colId xmlns:a16="http://schemas.microsoft.com/office/drawing/2014/main" val="20004"/>
@@ -14153,7 +14153,7 @@
                   </a:extLst>
                 </a:gridCol>
               </a:tblGrid>
-              <a:tr h="357531">
+              <a:tr h="370231">
                 <a:tc>
                   <a:txBody>
                     <a:bodyPr/>
@@ -14171,7 +14171,7 @@
                       </a:r>
                     </a:p>
                   </a:txBody>
-                  <a:tcPr>
+                  <a:tcPr marL="92354" marR="92354">
                     <a:solidFill>
                       <a:srgbClr val="002060"/>
                     </a:solidFill>
@@ -14194,7 +14194,7 @@
                       </a:r>
                     </a:p>
                   </a:txBody>
-                  <a:tcPr>
+                  <a:tcPr marL="92354" marR="92354">
                     <a:solidFill>
                       <a:srgbClr val="002060"/>
                     </a:solidFill>
@@ -14217,7 +14217,7 @@
                       </a:r>
                     </a:p>
                   </a:txBody>
-                  <a:tcPr>
+                  <a:tcPr marL="92354" marR="92354">
                     <a:solidFill>
                       <a:srgbClr val="002060"/>
                     </a:solidFill>
@@ -14240,7 +14240,7 @@
                       </a:r>
                     </a:p>
                   </a:txBody>
-                  <a:tcPr>
+                  <a:tcPr marL="92354" marR="92354">
                     <a:solidFill>
                       <a:srgbClr val="002060"/>
                     </a:solidFill>
@@ -14263,7 +14263,7 @@
                       </a:r>
                     </a:p>
                   </a:txBody>
-                  <a:tcPr>
+                  <a:tcPr marL="92354" marR="92354">
                     <a:solidFill>
                       <a:srgbClr val="002060"/>
                     </a:solidFill>
@@ -14275,7 +14275,7 @@
                   </a:ext>
                 </a:extLst>
               </a:tr>
-              <a:tr h="357531">
+              <a:tr h="370231">
                 <a:tc>
                   <a:txBody>
                     <a:bodyPr/>
@@ -14293,7 +14293,7 @@
                       </a:r>
                     </a:p>
                   </a:txBody>
-                  <a:tcPr>
+                  <a:tcPr marL="92354" marR="92354">
                     <a:solidFill>
                       <a:srgbClr val="FFFFFF"/>
                     </a:solidFill>
@@ -14316,7 +14316,7 @@
                       </a:r>
                     </a:p>
                   </a:txBody>
-                  <a:tcPr>
+                  <a:tcPr marL="92354" marR="92354">
                     <a:solidFill>
                       <a:srgbClr val="FFFFFF"/>
                     </a:solidFill>
@@ -14339,7 +14339,7 @@
                       </a:r>
                     </a:p>
                   </a:txBody>
-                  <a:tcPr>
+                  <a:tcPr marL="92354" marR="92354">
                     <a:solidFill>
                       <a:srgbClr val="FFFFFF"/>
                     </a:solidFill>
@@ -14362,7 +14362,7 @@
                       </a:r>
                     </a:p>
                   </a:txBody>
-                  <a:tcPr>
+                  <a:tcPr marL="92354" marR="92354">
                     <a:solidFill>
                       <a:srgbClr val="FFFFFF"/>
                     </a:solidFill>
@@ -14385,7 +14385,7 @@
                       </a:r>
                     </a:p>
                   </a:txBody>
-                  <a:tcPr>
+                  <a:tcPr marL="92354" marR="92354">
                     <a:solidFill>
                       <a:srgbClr val="FFFFFF"/>
                     </a:solidFill>
@@ -14397,7 +14397,7 @@
                   </a:ext>
                 </a:extLst>
               </a:tr>
-              <a:tr h="357531">
+              <a:tr h="370231">
                 <a:tc>
                   <a:txBody>
                     <a:bodyPr/>
@@ -14415,7 +14415,7 @@
                       </a:r>
                     </a:p>
                   </a:txBody>
-                  <a:tcPr>
+                  <a:tcPr marL="92354" marR="92354">
                     <a:solidFill>
                       <a:srgbClr val="F2F2F2"/>
                     </a:solidFill>
@@ -14438,7 +14438,7 @@
                       </a:r>
                     </a:p>
                   </a:txBody>
-                  <a:tcPr>
+                  <a:tcPr marL="92354" marR="92354">
                     <a:solidFill>
                       <a:srgbClr val="F2F2F2"/>
                     </a:solidFill>
@@ -14461,7 +14461,7 @@
                       </a:r>
                     </a:p>
                   </a:txBody>
-                  <a:tcPr>
+                  <a:tcPr marL="92354" marR="92354">
                     <a:solidFill>
                       <a:srgbClr val="F2F2F2"/>
                     </a:solidFill>
@@ -14484,7 +14484,7 @@
                       </a:r>
                     </a:p>
                   </a:txBody>
-                  <a:tcPr>
+                  <a:tcPr marL="92354" marR="92354">
                     <a:solidFill>
                       <a:srgbClr val="F2F2F2"/>
                     </a:solidFill>
@@ -14507,7 +14507,7 @@
                       </a:r>
                     </a:p>
                   </a:txBody>
-                  <a:tcPr>
+                  <a:tcPr marL="92354" marR="92354">
                     <a:solidFill>
                       <a:srgbClr val="F2F2F2"/>
                     </a:solidFill>
@@ -48353,7 +48353,7 @@
                           </a:solidFill>
                           <a:latin typeface="Arial"/>
                         </a:rPr>
-                        <a:t>5</a:t>
+                        <a:t>6</a:t>
                       </a:r>
                     </a:p>
                   </a:txBody>
@@ -48376,7 +48376,7 @@
                           </a:solidFill>
                           <a:latin typeface="Arial"/>
                         </a:rPr>
-                        <a:t>Csongor Lehmann</a:t>
+                        <a:t>David Cantero Del Campo</a:t>
                       </a:r>
                     </a:p>
                   </a:txBody>
@@ -48399,7 +48399,7 @@
                           </a:solidFill>
                           <a:latin typeface="Arial"/>
                         </a:rPr>
-                        <a:t>5,281</a:t>
+                        <a:t>5,092</a:t>
                       </a:r>
                     </a:p>
                   </a:txBody>
@@ -48429,7 +48429,7 @@
                           </a:solidFill>
                           <a:latin typeface="Arial"/>
                         </a:rPr>
-                        <a:t>6</a:t>
+                        <a:t>7</a:t>
                       </a:r>
                     </a:p>
                   </a:txBody>
@@ -48452,7 +48452,7 @@
                           </a:solidFill>
                           <a:latin typeface="Arial"/>
                         </a:rPr>
-                        <a:t>David Cantero Del Campo</a:t>
+                        <a:t>Luke Willian</a:t>
                       </a:r>
                     </a:p>
                   </a:txBody>
@@ -48475,7 +48475,7 @@
                           </a:solidFill>
                           <a:latin typeface="Arial"/>
                         </a:rPr>
-                        <a:t>5,092</a:t>
+                        <a:t>4,734</a:t>
                       </a:r>
                     </a:p>
                   </a:txBody>
@@ -48505,7 +48505,7 @@
                           </a:solidFill>
                           <a:latin typeface="Arial"/>
                         </a:rPr>
-                        <a:t>7</a:t>
+                        <a:t>13</a:t>
                       </a:r>
                     </a:p>
                   </a:txBody>
@@ -48528,7 +48528,7 @@
                           </a:solidFill>
                           <a:latin typeface="Arial"/>
                         </a:rPr>
-                        <a:t>Luke Willian</a:t>
+                        <a:t>Max Studer</a:t>
                       </a:r>
                     </a:p>
                   </a:txBody>
@@ -48551,7 +48551,7 @@
                           </a:solidFill>
                           <a:latin typeface="Arial"/>
                         </a:rPr>
-                        <a:t>4,734</a:t>
+                        <a:t>3,488</a:t>
                       </a:r>
                     </a:p>
                   </a:txBody>
@@ -48581,7 +48581,7 @@
                           </a:solidFill>
                           <a:latin typeface="Arial"/>
                         </a:rPr>
-                        <a:t>13</a:t>
+                        <a:t>14</a:t>
                       </a:r>
                     </a:p>
                   </a:txBody>
@@ -48604,7 +48604,7 @@
                           </a:solidFill>
                           <a:latin typeface="Arial"/>
                         </a:rPr>
-                        <a:t>Max Studer</a:t>
+                        <a:t>Tyler Mislawchuk</a:t>
                       </a:r>
                     </a:p>
                   </a:txBody>
@@ -48627,7 +48627,7 @@
                           </a:solidFill>
                           <a:latin typeface="Arial"/>
                         </a:rPr>
-                        <a:t>3,488</a:t>
+                        <a:t>3,342</a:t>
                       </a:r>
                     </a:p>
                   </a:txBody>
@@ -48657,7 +48657,7 @@
                           </a:solidFill>
                           <a:latin typeface="Arial"/>
                         </a:rPr>
-                        <a:t>14</a:t>
+                        <a:t>17</a:t>
                       </a:r>
                     </a:p>
                   </a:txBody>
@@ -48680,7 +48680,7 @@
                           </a:solidFill>
                           <a:latin typeface="Arial"/>
                         </a:rPr>
-                        <a:t>Tyler Mislawchuk</a:t>
+                        <a:t>Alberto Gonzalez Garcia</a:t>
                       </a:r>
                     </a:p>
                   </a:txBody>
@@ -48703,7 +48703,7 @@
                           </a:solidFill>
                           <a:latin typeface="Arial"/>
                         </a:rPr>
-                        <a:t>3,342</a:t>
+                        <a:t>3,188</a:t>
                       </a:r>
                     </a:p>
                   </a:txBody>
@@ -48733,7 +48733,7 @@
                           </a:solidFill>
                           <a:latin typeface="Arial"/>
                         </a:rPr>
-                        <a:t>17</a:t>
+                        <a:t>19</a:t>
                       </a:r>
                     </a:p>
                   </a:txBody>
@@ -48756,7 +48756,7 @@
                           </a:solidFill>
                           <a:latin typeface="Arial"/>
                         </a:rPr>
-                        <a:t>Alberto Gonzalez Garcia</a:t>
+                        <a:t>Callum McClusky</a:t>
                       </a:r>
                     </a:p>
                   </a:txBody>
@@ -48779,7 +48779,7 @@
                           </a:solidFill>
                           <a:latin typeface="Arial"/>
                         </a:rPr>
-                        <a:t>3,188</a:t>
+                        <a:t>2,983</a:t>
                       </a:r>
                     </a:p>
                   </a:txBody>
@@ -48809,7 +48809,7 @@
                           </a:solidFill>
                           <a:latin typeface="Arial"/>
                         </a:rPr>
-                        <a:t>19</a:t>
+                        <a:t>20</a:t>
                       </a:r>
                     </a:p>
                   </a:txBody>
@@ -48832,7 +48832,7 @@
                           </a:solidFill>
                           <a:latin typeface="Arial"/>
                         </a:rPr>
-                        <a:t>Callum McClusky</a:t>
+                        <a:t>John Reed</a:t>
                       </a:r>
                     </a:p>
                   </a:txBody>
@@ -48855,7 +48855,7 @@
                           </a:solidFill>
                           <a:latin typeface="Arial"/>
                         </a:rPr>
-                        <a:t>2,983</a:t>
+                        <a:t>2,898</a:t>
                       </a:r>
                     </a:p>
                   </a:txBody>
@@ -48885,7 +48885,7 @@
                           </a:solidFill>
                           <a:latin typeface="Arial"/>
                         </a:rPr>
-                        <a:t>20</a:t>
+                        <a:t>35</a:t>
                       </a:r>
                     </a:p>
                   </a:txBody>
@@ -48908,7 +48908,7 @@
                           </a:solidFill>
                           <a:latin typeface="Arial"/>
                         </a:rPr>
-                        <a:t>John Reed</a:t>
+                        <a:t>João Nuno Batista</a:t>
                       </a:r>
                     </a:p>
                   </a:txBody>
@@ -48931,7 +48931,7 @@
                           </a:solidFill>
                           <a:latin typeface="Arial"/>
                         </a:rPr>
-                        <a:t>2,898</a:t>
+                        <a:t>2,581</a:t>
                       </a:r>
                     </a:p>
                   </a:txBody>
@@ -48961,7 +48961,7 @@
                           </a:solidFill>
                           <a:latin typeface="Arial"/>
                         </a:rPr>
-                        <a:t>34</a:t>
+                        <a:t>38</a:t>
                       </a:r>
                     </a:p>
                   </a:txBody>
@@ -48984,7 +48984,7 @@
                           </a:solidFill>
                           <a:latin typeface="Arial"/>
                         </a:rPr>
-                        <a:t>João Nuno Batista</a:t>
+                        <a:t>Roberto Sanchez Mantecon</a:t>
                       </a:r>
                     </a:p>
                   </a:txBody>
@@ -49007,7 +49007,7 @@
                           </a:solidFill>
                           <a:latin typeface="Arial"/>
                         </a:rPr>
-                        <a:t>2,581</a:t>
+                        <a:t>2,530</a:t>
                       </a:r>
                     </a:p>
                   </a:txBody>
@@ -49617,7 +49617,7 @@
                           </a:solidFill>
                           <a:latin typeface="Arial"/>
                         </a:rPr>
-                        <a:t>4</a:t>
+                        <a:t>6</a:t>
                       </a:r>
                     </a:p>
                   </a:txBody>
@@ -49640,7 +49640,7 @@
                           </a:solidFill>
                           <a:latin typeface="Arial"/>
                         </a:rPr>
-                        <a:t>Jeanne Lehair</a:t>
+                        <a:t>Cassandre Beaugrand</a:t>
                       </a:r>
                     </a:p>
                   </a:txBody>
@@ -49663,7 +49663,7 @@
                           </a:solidFill>
                           <a:latin typeface="Arial"/>
                         </a:rPr>
-                        <a:t>6,306</a:t>
+                        <a:t>5,391</a:t>
                       </a:r>
                     </a:p>
                   </a:txBody>
@@ -49693,7 +49693,7 @@
                           </a:solidFill>
                           <a:latin typeface="Arial"/>
                         </a:rPr>
-                        <a:t>6</a:t>
+                        <a:t>10</a:t>
                       </a:r>
                     </a:p>
                   </a:txBody>
@@ -49716,7 +49716,7 @@
                           </a:solidFill>
                           <a:latin typeface="Arial"/>
                         </a:rPr>
-                        <a:t>Cassandre Beaugrand</a:t>
+                        <a:t>Diana Isakova</a:t>
                       </a:r>
                     </a:p>
                   </a:txBody>
@@ -49739,7 +49739,7 @@
                           </a:solidFill>
                           <a:latin typeface="Arial"/>
                         </a:rPr>
-                        <a:t>5,391</a:t>
+                        <a:t>4,750</a:t>
                       </a:r>
                     </a:p>
                   </a:txBody>
@@ -49769,7 +49769,7 @@
                           </a:solidFill>
                           <a:latin typeface="Arial"/>
                         </a:rPr>
-                        <a:t>10</a:t>
+                        <a:t>11</a:t>
                       </a:r>
                     </a:p>
                   </a:txBody>
@@ -49792,7 +49792,7 @@
                           </a:solidFill>
                           <a:latin typeface="Arial"/>
                         </a:rPr>
-                        <a:t>Diana Isakova</a:t>
+                        <a:t>Tanja Neubert</a:t>
                       </a:r>
                     </a:p>
                   </a:txBody>
@@ -49815,7 +49815,7 @@
                           </a:solidFill>
                           <a:latin typeface="Arial"/>
                         </a:rPr>
-                        <a:t>4,750</a:t>
+                        <a:t>4,583</a:t>
                       </a:r>
                     </a:p>
                   </a:txBody>
@@ -49845,7 +49845,7 @@
                           </a:solidFill>
                           <a:latin typeface="Arial"/>
                         </a:rPr>
-                        <a:t>11</a:t>
+                        <a:t>16</a:t>
                       </a:r>
                     </a:p>
                   </a:txBody>
@@ -49868,7 +49868,7 @@
                           </a:solidFill>
                           <a:latin typeface="Arial"/>
                         </a:rPr>
-                        <a:t>Tanja Neubert</a:t>
+                        <a:t>Gina Sereno</a:t>
                       </a:r>
                     </a:p>
                   </a:txBody>
@@ -49891,7 +49891,7 @@
                           </a:solidFill>
                           <a:latin typeface="Arial"/>
                         </a:rPr>
-                        <a:t>4,583</a:t>
+                        <a:t>3,205</a:t>
                       </a:r>
                     </a:p>
                   </a:txBody>
@@ -49921,7 +49921,7 @@
                           </a:solidFill>
                           <a:latin typeface="Arial"/>
                         </a:rPr>
-                        <a:t>15</a:t>
+                        <a:t>17</a:t>
                       </a:r>
                     </a:p>
                   </a:txBody>
@@ -49944,7 +49944,7 @@
                           </a:solidFill>
                           <a:latin typeface="Arial"/>
                         </a:rPr>
-                        <a:t>Sian Rainsley</a:t>
+                        <a:t>Roksana Slupek</a:t>
                       </a:r>
                     </a:p>
                   </a:txBody>
@@ -49967,7 +49967,7 @@
                           </a:solidFill>
                           <a:latin typeface="Arial"/>
                         </a:rPr>
-                        <a:t>3,568</a:t>
+                        <a:t>3,201</a:t>
                       </a:r>
                     </a:p>
                   </a:txBody>
@@ -49997,7 +49997,7 @@
                           </a:solidFill>
                           <a:latin typeface="Arial"/>
                         </a:rPr>
-                        <a:t>16</a:t>
+                        <a:t>18</a:t>
                       </a:r>
                     </a:p>
                   </a:txBody>
@@ -50020,7 +50020,7 @@
                           </a:solidFill>
                           <a:latin typeface="Arial"/>
                         </a:rPr>
-                        <a:t>Gina Sereno</a:t>
+                        <a:t>Valentina Riasova</a:t>
                       </a:r>
                     </a:p>
                   </a:txBody>
@@ -50043,7 +50043,7 @@
                           </a:solidFill>
                           <a:latin typeface="Arial"/>
                         </a:rPr>
-                        <a:t>3,205</a:t>
+                        <a:t>3,120</a:t>
                       </a:r>
                     </a:p>
                   </a:txBody>
@@ -50073,7 +50073,7 @@
                           </a:solidFill>
                           <a:latin typeface="Arial"/>
                         </a:rPr>
-                        <a:t>17</a:t>
+                        <a:t>19</a:t>
                       </a:r>
                     </a:p>
                   </a:txBody>
@@ -50096,7 +50096,7 @@
                           </a:solidFill>
                           <a:latin typeface="Arial"/>
                         </a:rPr>
-                        <a:t>Roksana Slupek</a:t>
+                        <a:t>Tilly Anema</a:t>
                       </a:r>
                     </a:p>
                   </a:txBody>
@@ -50119,7 +50119,7 @@
                           </a:solidFill>
                           <a:latin typeface="Arial"/>
                         </a:rPr>
-                        <a:t>3,201</a:t>
+                        <a:t>2,984</a:t>
                       </a:r>
                     </a:p>
                   </a:txBody>
@@ -50149,7 +50149,7 @@
                           </a:solidFill>
                           <a:latin typeface="Arial"/>
                         </a:rPr>
-                        <a:t>18</a:t>
+                        <a:t>23</a:t>
                       </a:r>
                     </a:p>
                   </a:txBody>
@@ -50172,7 +50172,7 @@
                           </a:solidFill>
                           <a:latin typeface="Arial"/>
                         </a:rPr>
-                        <a:t>Valentina Riasova</a:t>
+                        <a:t>Sara Guerrero Manso</a:t>
                       </a:r>
                     </a:p>
                   </a:txBody>
@@ -50195,7 +50195,7 @@
                           </a:solidFill>
                           <a:latin typeface="Arial"/>
                         </a:rPr>
-                        <a:t>3,120</a:t>
+                        <a:t>2,876</a:t>
                       </a:r>
                     </a:p>
                   </a:txBody>

</xml_diff>